<commit_message>
Investor pack complete; fix stale Atlas price and assembly-location references across teams
Co-Authored-By: Claude Opus 5.5 <noreply@anthropic.com>
Claude-Session: https://claude.ai/code/session_01UZ2GZFawefDh7zfRouJoUW
</commit_message>
<xml_diff>
--- a/investor/LORE_Pitch_Deck.pptx
+++ b/investor/LORE_Pitch_Deck.pptx
@@ -3256,7 +3256,7 @@
                 </a:solidFill>
                 <a:latin typeface="Inter"/>
               </a:rPr>
-              <a:t>Pre-seed  ·  $1.5M SAFE  ·  $12M post-money cap</a:t>
+              <a:t>Pre-seed  ·  $1.75M SAFE  ·  $12M post-money cap</a:t>
             </a:r>
           </a:p>
         </p:txBody>
@@ -3349,7 +3349,7 @@
       </p:sp>
       <p:pic>
         <p:nvPicPr>
-          <p:cNvPr id="8" name="Picture 7" descr="lineup.png"/>
+          <p:cNvPr id="8" name="Picture 7" descr="hero-square.png"/>
           <p:cNvPicPr>
             <a:picLocks noChangeAspect="1"/>
           </p:cNvPicPr>
@@ -3363,78 +3363,17 @@
         </p:blipFill>
         <p:spPr>
           <a:xfrm>
-            <a:off x="6675120" y="1992329"/>
-            <a:ext cx="4892040" cy="1501742"/>
+            <a:off x="6949440" y="685800"/>
+            <a:ext cx="4343400" cy="3017520"/>
           </a:xfrm>
           <a:prstGeom prst="rect">
             <a:avLst/>
           </a:prstGeom>
         </p:spPr>
       </p:pic>
-      <p:sp>
-        <p:nvSpPr>
-          <p:cNvPr id="9" name="TextBox 8"/>
-          <p:cNvSpPr txBox="1"/>
-          <p:nvPr/>
-        </p:nvSpPr>
-        <p:spPr>
-          <a:xfrm>
-            <a:off x="6812280" y="4846320"/>
-            <a:ext cx="4663440" cy="1097280"/>
-          </a:xfrm>
-          <a:prstGeom prst="rect">
-            <a:avLst/>
-          </a:prstGeom>
-          <a:noFill/>
-        </p:spPr>
-        <p:txBody>
-          <a:bodyPr wrap="square" lIns="0" rIns="0" tIns="0" bIns="0" anchor="t">
-            <a:spAutoFit/>
-          </a:bodyPr>
-          <a:lstStyle/>
-          <a:p>
-            <a:pPr algn="ctr">
-              <a:lnSpc>
-                <a:spcPct val="110000"/>
-              </a:lnSpc>
-              <a:spcAft>
-                <a:spcPts val="400"/>
-              </a:spcAft>
-            </a:pPr>
-            <a:r>
-              <a:rPr sz="1150" b="1" i="0">
-                <a:solidFill>
-                  <a:srgbClr val="14161A"/>
-                </a:solidFill>
-                <a:latin typeface="Inter"/>
-              </a:rPr>
-              <a:t>Pebble $149  ·  Square $299  ·  Atlas $599</a:t>
-            </a:r>
-          </a:p>
-          <a:p>
-            <a:pPr algn="ctr">
-              <a:lnSpc>
-                <a:spcPct val="110000"/>
-              </a:lnSpc>
-              <a:spcAft>
-                <a:spcPts val="400"/>
-              </a:spcAft>
-            </a:pPr>
-            <a:r>
-              <a:rPr sz="1150" b="0" i="0">
-                <a:solidFill>
-                  <a:srgbClr val="5A5D63"/>
-                </a:solidFill>
-                <a:latin typeface="Inter"/>
-              </a:rPr>
-              <a:t>Industrial-design renders (design/industrial). Not production units.</a:t>
-            </a:r>
-          </a:p>
-        </p:txBody>
-      </p:sp>
       <p:pic>
         <p:nvPicPr>
-          <p:cNvPr id="10" name="Picture 9" descr="lore-lockup-horizontal-bone-1600w.png"/>
+          <p:cNvPr id="9" name="Picture 8" descr="lineup.png"/>
           <p:cNvPicPr>
             <a:picLocks noChangeAspect="1"/>
           </p:cNvPicPr>
@@ -3448,6 +3387,91 @@
         </p:blipFill>
         <p:spPr>
           <a:xfrm>
+            <a:off x="7110499" y="3657600"/>
+            <a:ext cx="4021281" cy="1234440"/>
+          </a:xfrm>
+          <a:prstGeom prst="rect">
+            <a:avLst/>
+          </a:prstGeom>
+        </p:spPr>
+      </p:pic>
+      <p:sp>
+        <p:nvSpPr>
+          <p:cNvPr id="10" name="TextBox 9"/>
+          <p:cNvSpPr txBox="1"/>
+          <p:nvPr/>
+        </p:nvSpPr>
+        <p:spPr>
+          <a:xfrm>
+            <a:off x="6812280" y="5120640"/>
+            <a:ext cx="4663440" cy="1097280"/>
+          </a:xfrm>
+          <a:prstGeom prst="rect">
+            <a:avLst/>
+          </a:prstGeom>
+          <a:noFill/>
+        </p:spPr>
+        <p:txBody>
+          <a:bodyPr wrap="square" lIns="0" rIns="0" tIns="0" bIns="0" anchor="t">
+            <a:spAutoFit/>
+          </a:bodyPr>
+          <a:lstStyle/>
+          <a:p>
+            <a:pPr algn="ctr">
+              <a:lnSpc>
+                <a:spcPct val="110000"/>
+              </a:lnSpc>
+              <a:spcAft>
+                <a:spcPts val="400"/>
+              </a:spcAft>
+            </a:pPr>
+            <a:r>
+              <a:rPr sz="1150" b="1" i="0">
+                <a:solidFill>
+                  <a:srgbClr val="14161A"/>
+                </a:solidFill>
+                <a:latin typeface="Inter"/>
+              </a:rPr>
+              <a:t>Pebble $149  ·  Square $299  ·  Atlas $599</a:t>
+            </a:r>
+          </a:p>
+          <a:p>
+            <a:pPr algn="ctr">
+              <a:lnSpc>
+                <a:spcPct val="110000"/>
+              </a:lnSpc>
+              <a:spcAft>
+                <a:spcPts val="400"/>
+              </a:spcAft>
+            </a:pPr>
+            <a:r>
+              <a:rPr sz="1150" b="0" i="0">
+                <a:solidFill>
+                  <a:srgbClr val="5A5D63"/>
+                </a:solidFill>
+                <a:latin typeface="Inter"/>
+              </a:rPr>
+              <a:t>Industrial-design renders (design/industrial). Not production units.</a:t>
+            </a:r>
+          </a:p>
+        </p:txBody>
+      </p:sp>
+      <p:pic>
+        <p:nvPicPr>
+          <p:cNvPr id="11" name="Picture 10" descr="lore-lockup-horizontal-bone-1600w.png"/>
+          <p:cNvPicPr>
+            <a:picLocks noChangeAspect="1"/>
+          </p:cNvPicPr>
+          <p:nvPr/>
+        </p:nvPicPr>
+        <p:blipFill>
+          <a:blip r:embed="rId5"/>
+          <a:stretch>
+            <a:fillRect/>
+          </a:stretch>
+        </p:blipFill>
+        <p:spPr>
+          <a:xfrm>
             <a:off x="548640" y="6429032"/>
             <a:ext cx="822960" cy="199567"/>
           </a:xfrm>
@@ -3458,7 +3482,7 @@
       </p:pic>
       <p:sp>
         <p:nvSpPr>
-          <p:cNvPr id="11" name="TextBox 10"/>
+          <p:cNvPr id="12" name="TextBox 11"/>
           <p:cNvSpPr txBox="1"/>
           <p:nvPr/>
         </p:nvSpPr>
@@ -3500,7 +3524,7 @@
       </p:sp>
       <p:sp>
         <p:nvSpPr>
-          <p:cNvPr id="12" name="TextBox 11"/>
+          <p:cNvPr id="13" name="TextBox 12"/>
           <p:cNvSpPr txBox="1"/>
           <p:nvPr/>
         </p:nvSpPr>
@@ -3645,7 +3669,7 @@
                 </a:solidFill>
                 <a:latin typeface="Fraunces"/>
               </a:rPr>
-              <a:t>Hardware gets us in the pocket; LORE Pass, accessories and bookings compound.</a:t>
+              <a:t>Hardware gets us in; LORE Pass and bookings compound.</a:t>
             </a:r>
           </a:p>
         </p:txBody>
@@ -4943,7 +4967,7 @@
                 </a:solidFill>
                 <a:latin typeface="Inter"/>
               </a:rPr>
-              <a:t>3 SKUs, DTC first; retail only after returns &lt;5%</a:t>
+              <a:t>DTC first; retail after returns &lt;5%, led by Pebble + Atlas (D15)</a:t>
             </a:r>
           </a:p>
         </p:txBody>
@@ -5760,7 +5784,7 @@
                 </a:solidFill>
                 <a:latin typeface="Inter"/>
               </a:rPr>
-              <a:t>Sources: COMPANY.md, research/pricing-research.md, company/decisions-log.md D6, D8.</a:t>
+              <a:t>Sources: COMPANY.md, research/pricing-research.md, company/decisions-log.md D6, D8, D15.</a:t>
             </a:r>
           </a:p>
         </p:txBody>
@@ -5864,13 +5888,13 @@
               </a:spcAft>
             </a:pPr>
             <a:r>
-              <a:rPr sz="3000" b="0" i="0">
+              <a:rPr sz="2600" b="0" i="0">
                 <a:solidFill>
                   <a:srgbClr val="14161A"/>
                 </a:solidFill>
                 <a:latin typeface="Fraunces"/>
               </a:rPr>
-              <a:t>We found a hardware-margin problem early, and changed the product to fix it.</a:t>
+              <a:t>We found the margin problem early and changed the product.</a:t>
             </a:r>
           </a:p>
         </p:txBody>
@@ -6091,7 +6115,7 @@
           </a:bodyPr>
           <a:lstStyle/>
           <a:p>
-            <a:pPr algn="r">
+            <a:pPr algn="l">
               <a:lnSpc>
                 <a:spcPct val="110000"/>
               </a:lnSpc>
@@ -6133,7 +6157,7 @@
           </a:bodyPr>
           <a:lstStyle/>
           <a:p>
-            <a:pPr algn="r">
+            <a:pPr algn="l">
               <a:lnSpc>
                 <a:spcPct val="110000"/>
               </a:lnSpc>
@@ -6175,7 +6199,7 @@
           </a:bodyPr>
           <a:lstStyle/>
           <a:p>
-            <a:pPr algn="r">
+            <a:pPr algn="l">
               <a:lnSpc>
                 <a:spcPct val="110000"/>
               </a:lnSpc>
@@ -6259,7 +6283,7 @@
           </a:bodyPr>
           <a:lstStyle/>
           <a:p>
-            <a:pPr algn="r">
+            <a:pPr algn="l">
               <a:lnSpc>
                 <a:spcPct val="110000"/>
               </a:lnSpc>
@@ -6301,7 +6325,7 @@
           </a:bodyPr>
           <a:lstStyle/>
           <a:p>
-            <a:pPr algn="r">
+            <a:pPr algn="l">
               <a:lnSpc>
                 <a:spcPct val="110000"/>
               </a:lnSpc>
@@ -6343,7 +6367,7 @@
           </a:bodyPr>
           <a:lstStyle/>
           <a:p>
-            <a:pPr algn="r">
+            <a:pPr algn="l">
               <a:lnSpc>
                 <a:spcPct val="110000"/>
               </a:lnSpc>
@@ -6471,7 +6495,7 @@
           </a:bodyPr>
           <a:lstStyle/>
           <a:p>
-            <a:pPr algn="r">
+            <a:pPr algn="l">
               <a:lnSpc>
                 <a:spcPct val="110000"/>
               </a:lnSpc>
@@ -6513,7 +6537,7 @@
           </a:bodyPr>
           <a:lstStyle/>
           <a:p>
-            <a:pPr algn="r">
+            <a:pPr algn="l">
               <a:lnSpc>
                 <a:spcPct val="110000"/>
               </a:lnSpc>
@@ -6555,7 +6579,7 @@
           </a:bodyPr>
           <a:lstStyle/>
           <a:p>
-            <a:pPr algn="r">
+            <a:pPr algn="l">
               <a:lnSpc>
                 <a:spcPct val="110000"/>
               </a:lnSpc>
@@ -6639,7 +6663,7 @@
           </a:bodyPr>
           <a:lstStyle/>
           <a:p>
-            <a:pPr algn="r">
+            <a:pPr algn="l">
               <a:lnSpc>
                 <a:spcPct val="110000"/>
               </a:lnSpc>
@@ -6681,7 +6705,7 @@
           </a:bodyPr>
           <a:lstStyle/>
           <a:p>
-            <a:pPr algn="r">
+            <a:pPr algn="l">
               <a:lnSpc>
                 <a:spcPct val="110000"/>
               </a:lnSpc>
@@ -6723,7 +6747,7 @@
           </a:bodyPr>
           <a:lstStyle/>
           <a:p>
-            <a:pPr algn="r">
+            <a:pPr algn="l">
               <a:lnSpc>
                 <a:spcPct val="110000"/>
               </a:lnSpc>
@@ -6851,7 +6875,7 @@
           </a:bodyPr>
           <a:lstStyle/>
           <a:p>
-            <a:pPr algn="r">
+            <a:pPr algn="l">
               <a:lnSpc>
                 <a:spcPct val="110000"/>
               </a:lnSpc>
@@ -6893,7 +6917,7 @@
           </a:bodyPr>
           <a:lstStyle/>
           <a:p>
-            <a:pPr algn="r">
+            <a:pPr algn="l">
               <a:lnSpc>
                 <a:spcPct val="110000"/>
               </a:lnSpc>
@@ -6935,7 +6959,7 @@
           </a:bodyPr>
           <a:lstStyle/>
           <a:p>
-            <a:pPr algn="r">
+            <a:pPr algn="l">
               <a:lnSpc>
                 <a:spcPct val="110000"/>
               </a:lnSpc>
@@ -7199,7 +7223,7 @@
                 </a:solidFill>
                 <a:latin typeface="Inter"/>
               </a:rPr>
-              <a:t>if the Square cost-down fails, FY31 EBITDA is −$8.3M not +$0.8M. DVT gate Sep-2027: &gt;$205 ex-NRE → price $329. Square stays out of retail until then.</a:t>
+              <a:t>if the Square cost-down fails, FY31 EBITDA is −$8.3M not +$0.8M. DVT gate Sep-2027: &gt;$205 ex-NRE → price $329. Square is DTC-only until landed ≤$200 (D15).</a:t>
             </a:r>
           </a:p>
         </p:txBody>
@@ -7345,13 +7369,13 @@
               </a:spcAft>
             </a:pPr>
             <a:r>
-              <a:rPr sz="3000" b="0" i="0">
+              <a:rPr sz="2600" b="0" i="0">
                 <a:solidFill>
                   <a:srgbClr val="14161A"/>
                 </a:solidFill>
                 <a:latin typeface="Fraunces"/>
               </a:rPr>
-              <a:t>Stories sell on social; safety justifies the purchase; Kickstarter proves demand.</a:t>
+              <a:t>Stories sell; safety justifies; Kickstarter proves demand.</a:t>
             </a:r>
           </a:p>
         </p:txBody>
@@ -9078,7 +9102,7 @@
               </a:spcAft>
             </a:pPr>
             <a:r>
-              <a:rPr sz="3000" b="0" i="0">
+              <a:rPr sz="2600" b="0" i="0">
                 <a:solidFill>
                   <a:srgbClr val="14161A"/>
                 </a:solidFill>
@@ -9375,7 +9399,7 @@
         </p:nvSpPr>
         <p:spPr>
           <a:xfrm>
-            <a:off x="548640" y="3886200"/>
+            <a:off x="548640" y="3520440"/>
             <a:ext cx="2697480" cy="1325880"/>
           </a:xfrm>
           <a:prstGeom prst="rect">
@@ -9421,7 +9445,7 @@
         </p:nvSpPr>
         <p:spPr>
           <a:xfrm>
-            <a:off x="685800" y="3977639"/>
+            <a:off x="685800" y="3611880"/>
             <a:ext cx="2423160" cy="1188720"/>
           </a:xfrm>
           <a:prstGeom prst="rect">
@@ -9633,7 +9657,7 @@
         </p:nvSpPr>
         <p:spPr>
           <a:xfrm>
-            <a:off x="3337560" y="3886200"/>
+            <a:off x="3337560" y="3520440"/>
             <a:ext cx="2697480" cy="1325880"/>
           </a:xfrm>
           <a:prstGeom prst="rect">
@@ -9679,7 +9703,7 @@
         </p:nvSpPr>
         <p:spPr>
           <a:xfrm>
-            <a:off x="3474720" y="3977639"/>
+            <a:off x="3474720" y="3611880"/>
             <a:ext cx="2423160" cy="1188720"/>
           </a:xfrm>
           <a:prstGeom prst="rect">
@@ -9891,7 +9915,7 @@
         </p:nvSpPr>
         <p:spPr>
           <a:xfrm>
-            <a:off x="6126480" y="3886200"/>
+            <a:off x="6126480" y="3520440"/>
             <a:ext cx="2697480" cy="1325880"/>
           </a:xfrm>
           <a:prstGeom prst="rect">
@@ -9937,7 +9961,7 @@
         </p:nvSpPr>
         <p:spPr>
           <a:xfrm>
-            <a:off x="6263640" y="3977639"/>
+            <a:off x="6263640" y="3611880"/>
             <a:ext cx="2423160" cy="1188720"/>
           </a:xfrm>
           <a:prstGeom prst="rect">
@@ -10149,7 +10173,7 @@
         </p:nvSpPr>
         <p:spPr>
           <a:xfrm>
-            <a:off x="8915400" y="3886200"/>
+            <a:off x="8915400" y="3520440"/>
             <a:ext cx="2697480" cy="1325880"/>
           </a:xfrm>
           <a:prstGeom prst="rect">
@@ -10195,7 +10219,7 @@
         </p:nvSpPr>
         <p:spPr>
           <a:xfrm>
-            <a:off x="9052560" y="3977639"/>
+            <a:off x="9052560" y="3611880"/>
             <a:ext cx="2423160" cy="1188720"/>
           </a:xfrm>
           <a:prstGeom prst="rect">
@@ -10237,7 +10261,7 @@
         </p:nvSpPr>
         <p:spPr>
           <a:xfrm>
-            <a:off x="548640" y="5394960"/>
+            <a:off x="548640" y="5120640"/>
             <a:ext cx="11064240" cy="548640"/>
           </a:xfrm>
           <a:prstGeom prst="rect">
@@ -10421,13 +10445,13 @@
               </a:spcAft>
             </a:pPr>
             <a:r>
-              <a:rPr sz="3000" b="0" i="0">
+              <a:rPr sz="2600" b="0" i="0">
                 <a:solidFill>
                   <a:srgbClr val="14161A"/>
                 </a:solidFill>
                 <a:latin typeface="Fraunces"/>
               </a:rPr>
-              <a:t>A founder-led company today; the pre-seed buys the founding engineering team.</a:t>
+              <a:t>Founder-led today; the pre-seed buys the founding team.</a:t>
             </a:r>
           </a:p>
         </p:txBody>
@@ -10996,7 +11020,7 @@
           </a:bodyPr>
           <a:lstStyle/>
           <a:p>
-            <a:pPr algn="r">
+            <a:pPr algn="l">
               <a:lnSpc>
                 <a:spcPct val="110000"/>
               </a:lnSpc>
@@ -11038,7 +11062,7 @@
           </a:bodyPr>
           <a:lstStyle/>
           <a:p>
-            <a:pPr algn="r">
+            <a:pPr algn="l">
               <a:lnSpc>
                 <a:spcPct val="110000"/>
               </a:lnSpc>
@@ -11122,7 +11146,7 @@
           </a:bodyPr>
           <a:lstStyle/>
           <a:p>
-            <a:pPr algn="r">
+            <a:pPr algn="l">
               <a:lnSpc>
                 <a:spcPct val="110000"/>
               </a:lnSpc>
@@ -11164,7 +11188,7 @@
           </a:bodyPr>
           <a:lstStyle/>
           <a:p>
-            <a:pPr algn="r">
+            <a:pPr algn="l">
               <a:lnSpc>
                 <a:spcPct val="110000"/>
               </a:lnSpc>
@@ -11292,7 +11316,7 @@
           </a:bodyPr>
           <a:lstStyle/>
           <a:p>
-            <a:pPr algn="r">
+            <a:pPr algn="l">
               <a:lnSpc>
                 <a:spcPct val="110000"/>
               </a:lnSpc>
@@ -11334,7 +11358,7 @@
           </a:bodyPr>
           <a:lstStyle/>
           <a:p>
-            <a:pPr algn="r">
+            <a:pPr algn="l">
               <a:lnSpc>
                 <a:spcPct val="110000"/>
               </a:lnSpc>
@@ -11418,7 +11442,7 @@
           </a:bodyPr>
           <a:lstStyle/>
           <a:p>
-            <a:pPr algn="r">
+            <a:pPr algn="l">
               <a:lnSpc>
                 <a:spcPct val="110000"/>
               </a:lnSpc>
@@ -11460,7 +11484,7 @@
           </a:bodyPr>
           <a:lstStyle/>
           <a:p>
-            <a:pPr algn="r">
+            <a:pPr algn="l">
               <a:lnSpc>
                 <a:spcPct val="110000"/>
               </a:lnSpc>
@@ -11588,7 +11612,7 @@
           </a:bodyPr>
           <a:lstStyle/>
           <a:p>
-            <a:pPr algn="r">
+            <a:pPr algn="l">
               <a:lnSpc>
                 <a:spcPct val="110000"/>
               </a:lnSpc>
@@ -11630,7 +11654,7 @@
           </a:bodyPr>
           <a:lstStyle/>
           <a:p>
-            <a:pPr algn="r">
+            <a:pPr algn="l">
               <a:lnSpc>
                 <a:spcPct val="110000"/>
               </a:lnSpc>
@@ -11714,7 +11738,7 @@
           </a:bodyPr>
           <a:lstStyle/>
           <a:p>
-            <a:pPr algn="r">
+            <a:pPr algn="l">
               <a:lnSpc>
                 <a:spcPct val="110000"/>
               </a:lnSpc>
@@ -11756,7 +11780,7 @@
           </a:bodyPr>
           <a:lstStyle/>
           <a:p>
-            <a:pPr algn="r">
+            <a:pPr algn="l">
               <a:lnSpc>
                 <a:spcPct val="110000"/>
               </a:lnSpc>
@@ -11884,7 +11908,7 @@
           </a:bodyPr>
           <a:lstStyle/>
           <a:p>
-            <a:pPr algn="r">
+            <a:pPr algn="l">
               <a:lnSpc>
                 <a:spcPct val="110000"/>
               </a:lnSpc>
@@ -11926,7 +11950,7 @@
           </a:bodyPr>
           <a:lstStyle/>
           <a:p>
-            <a:pPr algn="r">
+            <a:pPr algn="l">
               <a:lnSpc>
                 <a:spcPct val="110000"/>
               </a:lnSpc>
@@ -12010,7 +12034,7 @@
           </a:bodyPr>
           <a:lstStyle/>
           <a:p>
-            <a:pPr algn="r">
+            <a:pPr algn="l">
               <a:lnSpc>
                 <a:spcPct val="110000"/>
               </a:lnSpc>
@@ -12052,7 +12076,7 @@
           </a:bodyPr>
           <a:lstStyle/>
           <a:p>
-            <a:pPr algn="r">
+            <a:pPr algn="l">
               <a:lnSpc>
                 <a:spcPct val="110000"/>
               </a:lnSpc>
@@ -12180,7 +12204,7 @@
           </a:bodyPr>
           <a:lstStyle/>
           <a:p>
-            <a:pPr algn="r">
+            <a:pPr algn="l">
               <a:lnSpc>
                 <a:spcPct val="110000"/>
               </a:lnSpc>
@@ -12222,7 +12246,7 @@
           </a:bodyPr>
           <a:lstStyle/>
           <a:p>
-            <a:pPr algn="r">
+            <a:pPr algn="l">
               <a:lnSpc>
                 <a:spcPct val="110000"/>
               </a:lnSpc>
@@ -12475,7 +12499,7 @@
                 </a:solidFill>
                 <a:latin typeface="Fraunces"/>
               </a:rPr>
-              <a:t>Base case: $111M revenue in FY2031; EBITDA-positive in FY2031.</a:t>
+              <a:t>Base case: $111M revenue and EBITDA-positive in FY2031.</a:t>
             </a:r>
           </a:p>
         </p:txBody>
@@ -14350,7 +14374,7 @@
                 </a:solidFill>
                 <a:latin typeface="Inter"/>
               </a:rPr>
-              <a:t>$55.5M equity modelled through FY31 (pre-seed → seed → A → B). Minimum cash $278k in Jun-27: Kickstarter timing is critical.</a:t>
+              <a:t>$55.5M total equity to break-even (D16): pre-seed → $6M seed → $3M seed-2 → $25M A → $20M B. Bear case needs ≈$72M. At $1.5M the pre-seed bottomed at $278k in Jun-27, so the round is now $1.75M (D14).</a:t>
             </a:r>
           </a:p>
           <a:p>
@@ -14670,7 +14694,7 @@
                 </a:solidFill>
                 <a:latin typeface="Fraunces"/>
               </a:rPr>
-              <a:t>$1.5M pre-seed SAFE
+              <a:t>$1.75M pre-seed SAFE
 $12M post-money cap</a:t>
             </a:r>
           </a:p>
@@ -14750,7 +14774,7 @@
                 </a:solidFill>
                 <a:latin typeface="Inter"/>
               </a:rPr>
-              <a:t>12.5% post-money at conversion (cap table, finance model).</a:t>
+              <a:t>≈14.6% at the $12M post-money cap. $1.5M + $250k top-up (D14).</a:t>
             </a:r>
           </a:p>
           <a:p>
@@ -14769,7 +14793,7 @@
                 </a:solidFill>
                 <a:latin typeface="Inter"/>
               </a:rPr>
-              <a:t>Runway: Nov 2026 to the Kickstarter payout (Jun/Jul 2027) and the $6M seed (Aug 2027). Tight by design: a one-month Kickstarter slip means cutting Atlas/ID spend.</a:t>
+              <a:t>Runway: Nov 2026 to the Kickstarter payout (Jun/Jul 2027) and the $6M seed (Aug 2027). The $250k top-up (D14) lifts the Jun-27 cash low from ~$278k to ~$0.5M.</a:t>
             </a:r>
           </a:p>
         </p:txBody>
@@ -14824,7 +14848,7 @@
         </p:nvSpPr>
         <p:spPr>
           <a:xfrm>
-            <a:off x="6675120" y="1143000"/>
+            <a:off x="6675120" y="1097280"/>
             <a:ext cx="3474720" cy="274320"/>
           </a:xfrm>
           <a:prstGeom prst="rect">
@@ -14866,7 +14890,7 @@
         </p:nvSpPr>
         <p:spPr>
           <a:xfrm>
-            <a:off x="10149840" y="1143000"/>
+            <a:off x="10149840" y="1097280"/>
             <a:ext cx="1463040" cy="274320"/>
           </a:xfrm>
           <a:prstGeom prst="rect">
@@ -14895,7 +14919,7 @@
                 </a:solidFill>
                 <a:latin typeface="Inter"/>
               </a:rPr>
-              <a:t>$500k · 33%</a:t>
+              <a:t>$500k · 29%</a:t>
             </a:r>
           </a:p>
         </p:txBody>
@@ -14908,7 +14932,7 @@
         </p:nvSpPr>
         <p:spPr>
           <a:xfrm>
-            <a:off x="6675120" y="1444752"/>
+            <a:off x="6675120" y="1399032"/>
             <a:ext cx="4937760" cy="82296"/>
           </a:xfrm>
           <a:prstGeom prst="rect">
@@ -14952,8 +14976,8 @@
         </p:nvSpPr>
         <p:spPr>
           <a:xfrm>
-            <a:off x="6675120" y="1444752"/>
-            <a:ext cx="1645920" cy="82296"/>
+            <a:off x="6675120" y="1399032"/>
+            <a:ext cx="1410788" cy="82296"/>
           </a:xfrm>
           <a:prstGeom prst="rect">
             <a:avLst/>
@@ -14996,8 +15020,8 @@
         </p:nvSpPr>
         <p:spPr>
           <a:xfrm>
-            <a:off x="6675120" y="1572768"/>
-            <a:ext cx="4937760" cy="274320"/>
+            <a:off x="6675120" y="1508760"/>
+            <a:ext cx="4937760" cy="228600"/>
           </a:xfrm>
           <a:prstGeom prst="rect">
             <a:avLst/>
@@ -15019,7 +15043,7 @@
               </a:spcAft>
             </a:pPr>
             <a:r>
-              <a:rPr sz="950" b="0" i="0">
+              <a:rPr sz="900" b="0" i="0">
                 <a:solidFill>
                   <a:srgbClr val="9AA0A6"/>
                 </a:solidFill>
@@ -15038,7 +15062,7 @@
         </p:nvSpPr>
         <p:spPr>
           <a:xfrm>
-            <a:off x="6675120" y="1892808"/>
+            <a:off x="6675120" y="1719072"/>
             <a:ext cx="3474720" cy="274320"/>
           </a:xfrm>
           <a:prstGeom prst="rect">
@@ -15080,7 +15104,7 @@
         </p:nvSpPr>
         <p:spPr>
           <a:xfrm>
-            <a:off x="10149840" y="1892808"/>
+            <a:off x="10149840" y="1719072"/>
             <a:ext cx="1463040" cy="274320"/>
           </a:xfrm>
           <a:prstGeom prst="rect">
@@ -15109,7 +15133,7 @@
                 </a:solidFill>
                 <a:latin typeface="Inter"/>
               </a:rPr>
-              <a:t>$322k · 21%</a:t>
+              <a:t>$322k · 18%</a:t>
             </a:r>
           </a:p>
         </p:txBody>
@@ -15122,7 +15146,7 @@
         </p:nvSpPr>
         <p:spPr>
           <a:xfrm>
-            <a:off x="6675120" y="2194560"/>
+            <a:off x="6675120" y="2020824"/>
             <a:ext cx="4937760" cy="82296"/>
           </a:xfrm>
           <a:prstGeom prst="rect">
@@ -15166,8 +15190,8 @@
         </p:nvSpPr>
         <p:spPr>
           <a:xfrm>
-            <a:off x="6675120" y="2194560"/>
-            <a:ext cx="1059972" cy="82296"/>
+            <a:off x="6675120" y="2020824"/>
+            <a:ext cx="908547" cy="82296"/>
           </a:xfrm>
           <a:prstGeom prst="rect">
             <a:avLst/>
@@ -15210,8 +15234,8 @@
         </p:nvSpPr>
         <p:spPr>
           <a:xfrm>
-            <a:off x="6675120" y="2322576"/>
-            <a:ext cx="4937760" cy="274320"/>
+            <a:off x="6675120" y="2130552"/>
+            <a:ext cx="4937760" cy="228600"/>
           </a:xfrm>
           <a:prstGeom prst="rect">
             <a:avLst/>
@@ -15233,7 +15257,7 @@
               </a:spcAft>
             </a:pPr>
             <a:r>
-              <a:rPr sz="950" b="0" i="0">
+              <a:rPr sz="900" b="0" i="0">
                 <a:solidFill>
                   <a:srgbClr val="9AA0A6"/>
                 </a:solidFill>
@@ -15252,7 +15276,7 @@
         </p:nvSpPr>
         <p:spPr>
           <a:xfrm>
-            <a:off x="6675120" y="2642616"/>
+            <a:off x="6675120" y="2340864"/>
             <a:ext cx="3474720" cy="274320"/>
           </a:xfrm>
           <a:prstGeom prst="rect">
@@ -15294,7 +15318,7 @@
         </p:nvSpPr>
         <p:spPr>
           <a:xfrm>
-            <a:off x="10149840" y="2642616"/>
+            <a:off x="10149840" y="2340864"/>
             <a:ext cx="1463040" cy="274320"/>
           </a:xfrm>
           <a:prstGeom prst="rect">
@@ -15323,7 +15347,7 @@
                 </a:solidFill>
                 <a:latin typeface="Inter"/>
               </a:rPr>
-              <a:t>$210k · 14%</a:t>
+              <a:t>$210k · 12%</a:t>
             </a:r>
           </a:p>
         </p:txBody>
@@ -15336,7 +15360,7 @@
         </p:nvSpPr>
         <p:spPr>
           <a:xfrm>
-            <a:off x="6675120" y="2944368"/>
+            <a:off x="6675120" y="2642616"/>
             <a:ext cx="4937760" cy="82296"/>
           </a:xfrm>
           <a:prstGeom prst="rect">
@@ -15380,8 +15404,8 @@
         </p:nvSpPr>
         <p:spPr>
           <a:xfrm>
-            <a:off x="6675120" y="2944368"/>
-            <a:ext cx="691286" cy="82296"/>
+            <a:off x="6675120" y="2642616"/>
+            <a:ext cx="592531" cy="82296"/>
           </a:xfrm>
           <a:prstGeom prst="rect">
             <a:avLst/>
@@ -15424,8 +15448,8 @@
         </p:nvSpPr>
         <p:spPr>
           <a:xfrm>
-            <a:off x="6675120" y="3072384"/>
-            <a:ext cx="4937760" cy="274320"/>
+            <a:off x="6675120" y="2752344"/>
+            <a:ext cx="4937760" cy="228600"/>
           </a:xfrm>
           <a:prstGeom prst="rect">
             <a:avLst/>
@@ -15447,7 +15471,7 @@
               </a:spcAft>
             </a:pPr>
             <a:r>
-              <a:rPr sz="950" b="0" i="0">
+              <a:rPr sz="900" b="0" i="0">
                 <a:solidFill>
                   <a:srgbClr val="9AA0A6"/>
                 </a:solidFill>
@@ -15466,7 +15490,7 @@
         </p:nvSpPr>
         <p:spPr>
           <a:xfrm>
-            <a:off x="6675120" y="3392424"/>
+            <a:off x="6675120" y="2962656"/>
             <a:ext cx="3474720" cy="274320"/>
           </a:xfrm>
           <a:prstGeom prst="rect">
@@ -15508,7 +15532,7 @@
         </p:nvSpPr>
         <p:spPr>
           <a:xfrm>
-            <a:off x="10149840" y="3392424"/>
+            <a:off x="10149840" y="2962656"/>
             <a:ext cx="1463040" cy="274320"/>
           </a:xfrm>
           <a:prstGeom prst="rect">
@@ -15537,7 +15561,7 @@
                 </a:solidFill>
                 <a:latin typeface="Inter"/>
               </a:rPr>
-              <a:t>$168k · 11%</a:t>
+              <a:t>$168k · 10%</a:t>
             </a:r>
           </a:p>
         </p:txBody>
@@ -15550,7 +15574,7 @@
         </p:nvSpPr>
         <p:spPr>
           <a:xfrm>
-            <a:off x="6675120" y="3694176"/>
+            <a:off x="6675120" y="3264408"/>
             <a:ext cx="4937760" cy="82296"/>
           </a:xfrm>
           <a:prstGeom prst="rect">
@@ -15594,8 +15618,8 @@
         </p:nvSpPr>
         <p:spPr>
           <a:xfrm>
-            <a:off x="6675120" y="3694176"/>
-            <a:ext cx="553029" cy="82296"/>
+            <a:off x="6675120" y="3264408"/>
+            <a:ext cx="474024" cy="82296"/>
           </a:xfrm>
           <a:prstGeom prst="rect">
             <a:avLst/>
@@ -15638,8 +15662,8 @@
         </p:nvSpPr>
         <p:spPr>
           <a:xfrm>
-            <a:off x="6675120" y="3822192"/>
-            <a:ext cx="4937760" cy="274320"/>
+            <a:off x="6675120" y="3374136"/>
+            <a:ext cx="4937760" cy="228600"/>
           </a:xfrm>
           <a:prstGeom prst="rect">
             <a:avLst/>
@@ -15661,7 +15685,7 @@
               </a:spcAft>
             </a:pPr>
             <a:r>
-              <a:rPr sz="950" b="0" i="0">
+              <a:rPr sz="900" b="0" i="0">
                 <a:solidFill>
                   <a:srgbClr val="9AA0A6"/>
                 </a:solidFill>
@@ -15680,7 +15704,7 @@
         </p:nvSpPr>
         <p:spPr>
           <a:xfrm>
-            <a:off x="6675120" y="4142232"/>
+            <a:off x="6675120" y="3584448"/>
             <a:ext cx="3474720" cy="274320"/>
           </a:xfrm>
           <a:prstGeom prst="rect">
@@ -15722,7 +15746,7 @@
         </p:nvSpPr>
         <p:spPr>
           <a:xfrm>
-            <a:off x="10149840" y="4142232"/>
+            <a:off x="10149840" y="3584448"/>
             <a:ext cx="1463040" cy="274320"/>
           </a:xfrm>
           <a:prstGeom prst="rect">
@@ -15751,7 +15775,7 @@
                 </a:solidFill>
                 <a:latin typeface="Inter"/>
               </a:rPr>
-              <a:t>$40k · 3%</a:t>
+              <a:t>$40k · 2%</a:t>
             </a:r>
           </a:p>
         </p:txBody>
@@ -15764,7 +15788,7 @@
         </p:nvSpPr>
         <p:spPr>
           <a:xfrm>
-            <a:off x="6675120" y="4443984"/>
+            <a:off x="6675120" y="3886200"/>
             <a:ext cx="4937760" cy="82296"/>
           </a:xfrm>
           <a:prstGeom prst="rect">
@@ -15808,8 +15832,8 @@
         </p:nvSpPr>
         <p:spPr>
           <a:xfrm>
-            <a:off x="6675120" y="4443984"/>
-            <a:ext cx="131673" cy="82296"/>
+            <a:off x="6675120" y="3886200"/>
+            <a:ext cx="112863" cy="82296"/>
           </a:xfrm>
           <a:prstGeom prst="rect">
             <a:avLst/>
@@ -15852,8 +15876,8 @@
         </p:nvSpPr>
         <p:spPr>
           <a:xfrm>
-            <a:off x="6675120" y="4572000"/>
-            <a:ext cx="4937760" cy="274320"/>
+            <a:off x="6675120" y="3995928"/>
+            <a:ext cx="4937760" cy="228600"/>
           </a:xfrm>
           <a:prstGeom prst="rect">
             <a:avLst/>
@@ -15875,7 +15899,7 @@
               </a:spcAft>
             </a:pPr>
             <a:r>
-              <a:rPr sz="950" b="0" i="0">
+              <a:rPr sz="900" b="0" i="0">
                 <a:solidFill>
                   <a:srgbClr val="9AA0A6"/>
                 </a:solidFill>
@@ -15894,7 +15918,7 @@
         </p:nvSpPr>
         <p:spPr>
           <a:xfrm>
-            <a:off x="6675120" y="4892040"/>
+            <a:off x="6675120" y="4206240"/>
             <a:ext cx="3474720" cy="274320"/>
           </a:xfrm>
           <a:prstGeom prst="rect">
@@ -15923,7 +15947,7 @@
                 </a:solidFill>
                 <a:latin typeface="Inter"/>
               </a:rPr>
-              <a:t>Cash buffer at Kickstarter</a:t>
+              <a:t>Cash buffer through Kickstarter</a:t>
             </a:r>
           </a:p>
         </p:txBody>
@@ -15936,7 +15960,7 @@
         </p:nvSpPr>
         <p:spPr>
           <a:xfrm>
-            <a:off x="10149840" y="4892040"/>
+            <a:off x="10149840" y="4206240"/>
             <a:ext cx="1463040" cy="274320"/>
           </a:xfrm>
           <a:prstGeom prst="rect">
@@ -15965,7 +15989,7 @@
                 </a:solidFill>
                 <a:latin typeface="Inter"/>
               </a:rPr>
-              <a:t>$260k · 17%</a:t>
+              <a:t>$510k · 29%</a:t>
             </a:r>
           </a:p>
         </p:txBody>
@@ -15978,7 +16002,7 @@
         </p:nvSpPr>
         <p:spPr>
           <a:xfrm>
-            <a:off x="6675120" y="5193792"/>
+            <a:off x="6675120" y="4507992"/>
             <a:ext cx="4937760" cy="82296"/>
           </a:xfrm>
           <a:prstGeom prst="rect">
@@ -16022,8 +16046,8 @@
         </p:nvSpPr>
         <p:spPr>
           <a:xfrm>
-            <a:off x="6675120" y="5193792"/>
-            <a:ext cx="855878" cy="82296"/>
+            <a:off x="6675120" y="4507992"/>
+            <a:ext cx="1439004" cy="82296"/>
           </a:xfrm>
           <a:prstGeom prst="rect">
             <a:avLst/>
@@ -16066,8 +16090,8 @@
         </p:nvSpPr>
         <p:spPr>
           <a:xfrm>
-            <a:off x="6675120" y="5321808"/>
-            <a:ext cx="4937760" cy="274320"/>
+            <a:off x="6675120" y="4617720"/>
+            <a:ext cx="4937760" cy="228600"/>
           </a:xfrm>
           <a:prstGeom prst="rect">
             <a:avLst/>
@@ -16089,13 +16113,13 @@
               </a:spcAft>
             </a:pPr>
             <a:r>
-              <a:rPr sz="950" b="0" i="0">
+              <a:rPr sz="900" b="0" i="0">
                 <a:solidFill>
                   <a:srgbClr val="9AA0A6"/>
                 </a:solidFill>
                 <a:latin typeface="Inter"/>
               </a:rPr>
-              <a:t>Model low point ~$278k in Jun-27, before the Jul-27 payout</a:t>
+              <a:t>Low point ~$528k in Jun-27 with the D14 top-up (was $278k)</a:t>
             </a:r>
           </a:p>
         </p:txBody>
@@ -16762,7 +16786,7 @@
                 </a:solidFill>
                 <a:latin typeface="Inter"/>
               </a:rPr>
-              <a:t>Head down, not looking up</a:t>
+              <a:t>Eyes on the screen</a:t>
             </a:r>
           </a:p>
         </p:txBody>
@@ -17523,7 +17547,7 @@
               </a:spcAft>
             </a:pPr>
             <a:r>
-              <a:rPr sz="3000" b="0" i="0">
+              <a:rPr sz="2600" b="0" i="0">
                 <a:solidFill>
                   <a:srgbClr val="14161A"/>
                 </a:solidFill>
@@ -18415,7 +18439,7 @@
               </a:spcAft>
             </a:pPr>
             <a:r>
-              <a:rPr sz="3000" b="0" i="0">
+              <a:rPr sz="2600" b="0" i="0">
                 <a:solidFill>
                   <a:srgbClr val="14161A"/>
                 </a:solidFill>
@@ -20155,7 +20179,7 @@
         </p:nvSpPr>
         <p:spPr>
           <a:xfrm>
-            <a:off x="548640" y="5669280"/>
+            <a:off x="548640" y="5486400"/>
             <a:ext cx="11064240" cy="365760"/>
           </a:xfrm>
           <a:prstGeom prst="rect">
@@ -20357,7 +20381,7 @@
               </a:spcAft>
             </a:pPr>
             <a:r>
-              <a:rPr sz="3000" b="0" i="0">
+              <a:rPr sz="2600" b="0" i="0">
                 <a:solidFill>
                   <a:srgbClr val="14161A"/>
                 </a:solidFill>
@@ -21404,7 +21428,7 @@
               </a:spcAft>
             </a:pPr>
             <a:r>
-              <a:rPr sz="2200" b="0" i="0">
+              <a:rPr sz="1800" b="0" i="0">
                 <a:solidFill>
                   <a:srgbClr val="C4623A"/>
                 </a:solidFill>
@@ -21423,8 +21447,8 @@
         </p:nvSpPr>
         <p:spPr>
           <a:xfrm>
-            <a:off x="7543800" y="2423160"/>
-            <a:ext cx="4114800" cy="1828800"/>
+            <a:off x="7543800" y="2148840"/>
+            <a:ext cx="4114800" cy="2194560"/>
           </a:xfrm>
           <a:prstGeom prst="rect">
             <a:avLst/>
@@ -21788,13 +21812,13 @@
               </a:spcAft>
             </a:pPr>
             <a:r>
-              <a:rPr sz="3000" b="0" i="0">
+              <a:rPr sz="2600" b="0" i="0">
                 <a:solidFill>
                   <a:srgbClr val="14161A"/>
                 </a:solidFill>
                 <a:latin typeface="Fraunces"/>
               </a:rPr>
-              <a:t>A phone PWA runs the real story engine on a 1.93 km walk, Pantheon to Trevi.</a:t>
+              <a:t>The real story engine, walking Pantheon to Trevi (1.93 km).</a:t>
             </a:r>
           </a:p>
         </p:txBody>
@@ -23299,7 +23323,7 @@
               </a:spcAft>
             </a:pPr>
             <a:r>
-              <a:rPr sz="3000" b="0" i="0">
+              <a:rPr sz="2600" b="0" i="0">
                 <a:solidFill>
                   <a:srgbClr val="14161A"/>
                 </a:solidFill>
@@ -23426,7 +23450,7 @@
         </p:nvSpPr>
         <p:spPr>
           <a:xfrm>
-            <a:off x="548640" y="1600200"/>
+            <a:off x="548640" y="1554480"/>
             <a:ext cx="3840480" cy="640080"/>
           </a:xfrm>
           <a:prstGeom prst="rect">
@@ -23468,7 +23492,7 @@
         </p:nvSpPr>
         <p:spPr>
           <a:xfrm>
-            <a:off x="548640" y="2258568"/>
+            <a:off x="548640" y="2212848"/>
             <a:ext cx="3840480" cy="640080"/>
           </a:xfrm>
           <a:prstGeom prst="rect">
@@ -23510,7 +23534,7 @@
         </p:nvSpPr>
         <p:spPr>
           <a:xfrm>
-            <a:off x="548640" y="2679192"/>
+            <a:off x="548640" y="2606040"/>
             <a:ext cx="3840480" cy="640080"/>
           </a:xfrm>
           <a:prstGeom prst="rect">
@@ -23552,7 +23576,7 @@
         </p:nvSpPr>
         <p:spPr>
           <a:xfrm>
-            <a:off x="548640" y="3337560"/>
+            <a:off x="548640" y="3264408"/>
             <a:ext cx="3840480" cy="640080"/>
           </a:xfrm>
           <a:prstGeom prst="rect">
@@ -23594,7 +23618,7 @@
         </p:nvSpPr>
         <p:spPr>
           <a:xfrm>
-            <a:off x="548640" y="3758184"/>
+            <a:off x="548640" y="3657600"/>
             <a:ext cx="3840480" cy="640080"/>
           </a:xfrm>
           <a:prstGeom prst="rect">
@@ -23636,7 +23660,7 @@
         </p:nvSpPr>
         <p:spPr>
           <a:xfrm>
-            <a:off x="548640" y="4416552"/>
+            <a:off x="548640" y="4315968"/>
             <a:ext cx="3840480" cy="640080"/>
           </a:xfrm>
           <a:prstGeom prst="rect">
@@ -23678,7 +23702,7 @@
         </p:nvSpPr>
         <p:spPr>
           <a:xfrm>
-            <a:off x="548640" y="4837176"/>
+            <a:off x="548640" y="4709160"/>
             <a:ext cx="3840480" cy="640080"/>
           </a:xfrm>
           <a:prstGeom prst="rect">
@@ -23720,7 +23744,7 @@
         </p:nvSpPr>
         <p:spPr>
           <a:xfrm>
-            <a:off x="548640" y="5495544"/>
+            <a:off x="548640" y="5367528"/>
             <a:ext cx="3840480" cy="640080"/>
           </a:xfrm>
           <a:prstGeom prst="rect">
@@ -24013,7 +24037,7 @@
                 </a:solidFill>
                 <a:latin typeface="Fraunces"/>
               </a:rPr>
-              <a:t>Everything exists. Nothing does it together, standalone, with verified facts.</a:t>
+              <a:t>Nothing else is standalone, travel-first and verified.</a:t>
             </a:r>
           </a:p>
         </p:txBody>
@@ -24304,7 +24328,7 @@
           </a:bodyPr>
           <a:lstStyle/>
           <a:p>
-            <a:pPr algn="r">
+            <a:pPr algn="l">
               <a:lnSpc>
                 <a:spcPct val="110000"/>
               </a:lnSpc>
@@ -24346,7 +24370,7 @@
           </a:bodyPr>
           <a:lstStyle/>
           <a:p>
-            <a:pPr algn="r">
+            <a:pPr algn="l">
               <a:lnSpc>
                 <a:spcPct val="110000"/>
               </a:lnSpc>
@@ -24430,7 +24454,7 @@
           </a:bodyPr>
           <a:lstStyle/>
           <a:p>
-            <a:pPr algn="r">
+            <a:pPr algn="l">
               <a:lnSpc>
                 <a:spcPct val="110000"/>
               </a:lnSpc>
@@ -24472,7 +24496,7 @@
           </a:bodyPr>
           <a:lstStyle/>
           <a:p>
-            <a:pPr algn="r">
+            <a:pPr algn="l">
               <a:lnSpc>
                 <a:spcPct val="110000"/>
               </a:lnSpc>
@@ -24600,7 +24624,7 @@
           </a:bodyPr>
           <a:lstStyle/>
           <a:p>
-            <a:pPr algn="r">
+            <a:pPr algn="l">
               <a:lnSpc>
                 <a:spcPct val="110000"/>
               </a:lnSpc>
@@ -24642,7 +24666,7 @@
           </a:bodyPr>
           <a:lstStyle/>
           <a:p>
-            <a:pPr algn="r">
+            <a:pPr algn="l">
               <a:lnSpc>
                 <a:spcPct val="110000"/>
               </a:lnSpc>
@@ -24726,7 +24750,7 @@
           </a:bodyPr>
           <a:lstStyle/>
           <a:p>
-            <a:pPr algn="r">
+            <a:pPr algn="l">
               <a:lnSpc>
                 <a:spcPct val="110000"/>
               </a:lnSpc>
@@ -24768,7 +24792,7 @@
           </a:bodyPr>
           <a:lstStyle/>
           <a:p>
-            <a:pPr algn="r">
+            <a:pPr algn="l">
               <a:lnSpc>
                 <a:spcPct val="110000"/>
               </a:lnSpc>
@@ -24896,7 +24920,7 @@
           </a:bodyPr>
           <a:lstStyle/>
           <a:p>
-            <a:pPr algn="r">
+            <a:pPr algn="l">
               <a:lnSpc>
                 <a:spcPct val="110000"/>
               </a:lnSpc>
@@ -24938,7 +24962,7 @@
           </a:bodyPr>
           <a:lstStyle/>
           <a:p>
-            <a:pPr algn="r">
+            <a:pPr algn="l">
               <a:lnSpc>
                 <a:spcPct val="110000"/>
               </a:lnSpc>

</xml_diff>